<commit_message>
Carry ChatClientFactory into Module 3 onward
Module 3 moves Module 2b's ChatClientFactory from MiniCode.Cli into
MiniCode.Agent, and every later folder carries it. CodingAgentFactory no
longer names OpenAI or reads the environment; its client lines become
IChatClient chatClient = ChatClientFactory.Create().

Module 18's MINICODE_MODEL override and the Phase 4 Capstone's Length
check now land in ChatClientFactory instead of CodingAgentFactory, so
exactly one type still reads the environment. The Module 3, Module 18,
Phase 1 and Phase 4 lessons and decks follow the moved code.

Co-Authored-By: Claude Opus 5.5 <noreply@anthropic.com>
</commit_message>
<xml_diff>
--- a/Projects/Module03-DesigningTheMiniCodeSolution/Module03 - Designing the MiniCode Solution.pptx
+++ b/Projects/Module03-DesigningTheMiniCodeSolution/Module03 - Designing the MiniCode Solution.pptx
@@ -508,7 +508,7 @@
           <a:p>
             <a:r>
               <a:rPr lang="en-US" dirty="0"/>
-              <a:t>This structure is what Phase 1 Capstone — Repository Explorer (v0.1) consolidates. Module 2’s exact code is carried forward here; it just moves.</a:t>
+              <a:t>This structure is what Phase 1 Capstone — Repository Explorer (v0.1) consolidates. Module 2b’s exact code is carried forward here; it just moves.</a:t>
             </a:r>
             <a:endParaRPr lang="en-US" dirty="0"/>
           </a:p>
@@ -1546,7 +1546,7 @@
                 <a:ea typeface="Calibri" pitchFamily="34" charset="-122"/>
                 <a:cs typeface="Calibri" pitchFamily="34" charset="-120"/>
               </a:rPr>
-              <a:t>We take Module 2's single file and split it across the five projects MiniCode lives in for the rest of the course — then fix the direction dependencies may flow. Nothing new happens on screen: what changes is that the terminal no longer knows what a model is.</a:t>
+              <a:t>We take Module 2b's two files and split them across the five projects MiniCode lives in for the rest of the course — then fix the direction dependencies may flow. Nothing new happens on screen: what changes is that the terminal no longer knows what a model is.</a:t>
             </a:r>
             <a:endParaRPr lang="en-US" sz="1600" dirty="0"/>
           </a:p>
@@ -1605,7 +1605,7 @@
                 <a:ea typeface="Courier New" pitchFamily="34" charset="-122"/>
                 <a:cs typeface="Courier New" pitchFamily="34" charset="-120"/>
               </a:rPr>
-              <a:t>Module02-MicrosoftAgentFrameworkFundamentals/ — its four objects move out of Program.cs into the projects that own them.</a:t>
+              <a:t>Module02b-ConfiguringModelProviders/ — its four objects and ChatClientFactory move out of MiniCode.Cli into the projects that own them.</a:t>
             </a:r>
             <a:endParaRPr lang="en-US" sz="950" dirty="0"/>
           </a:p>
@@ -5305,7 +5305,7 @@
                 <a:ea typeface="Courier New" pitchFamily="34" charset="-122"/>
                 <a:cs typeface="Courier New" pitchFamily="34" charset="-120"/>
               </a:rPr>
-              <a:t>// The composition root: the one place that names</a:t>
+              <a:t>// The composition root assembles the agent;</a:t>
             </a:r>
             <a:endParaRPr lang="en-US" sz="950" dirty="0"/>
           </a:p>
@@ -5325,7 +5325,7 @@
                 <a:ea typeface="Courier New" pitchFamily="34" charset="-122"/>
                 <a:cs typeface="Courier New" pitchFamily="34" charset="-120"/>
               </a:rPr>
-              <a:t>// OpenAI, reads the API key, assembles the agent.</a:t>
+              <a:t>// ChatClientFactory supplies the model.</a:t>
             </a:r>
             <a:endParaRPr lang="en-US" sz="950" dirty="0"/>
           </a:p>
@@ -5340,7 +5340,7 @@
         <p:spPr>
           <a:xfrm>
             <a:off x="6638544" y="2313432"/>
-            <a:ext cx="4690872" cy="2511552"/>
+            <a:ext cx="4690872" cy="1444752"/>
           </a:xfrm>
           <a:prstGeom prst="rect">
             <a:avLst/>
@@ -5367,7 +5367,7 @@
                 <a:ea typeface="Courier New" pitchFamily="34" charset="-122"/>
                 <a:cs typeface="Courier New" pitchFamily="34" charset="-120"/>
               </a:rPr>
-              <a:t>private const string ModelId = "gpt-4.1-mini";</a:t>
+              <a:t>public static async Task&lt;ICodingAgent&gt;</a:t>
             </a:r>
             <a:endParaRPr lang="en-US" sz="950" dirty="0"/>
           </a:p>
@@ -5387,7 +5387,7 @@
                 <a:ea typeface="Courier New" pitchFamily="34" charset="-122"/>
                 <a:cs typeface="Courier New" pitchFamily="34" charset="-120"/>
               </a:rPr>
-              <a:t>private const string ApiKeyVariable =</a:t>
+              <a:t>    CreateAsync(CancellationToken ct = default)</a:t>
             </a:r>
             <a:endParaRPr lang="en-US" sz="950" dirty="0"/>
           </a:p>
@@ -5407,7 +5407,7 @@
                 <a:ea typeface="Courier New" pitchFamily="34" charset="-122"/>
                 <a:cs typeface="Courier New" pitchFamily="34" charset="-120"/>
               </a:rPr>
-              <a:t>    "OPENAI_API_KEY";</a:t>
+              <a:t>{</a:t>
             </a:r>
             <a:endParaRPr lang="en-US" sz="950" dirty="0"/>
           </a:p>
@@ -5427,7 +5427,7 @@
                 <a:ea typeface="Courier New" pitchFamily="34" charset="-122"/>
                 <a:cs typeface="Courier New" pitchFamily="34" charset="-120"/>
               </a:rPr>
-              <a:t>public static async Task&lt;ICodingAgent&gt;</a:t>
+              <a:t>    IChatClient chatClient =</a:t>
             </a:r>
             <a:endParaRPr lang="en-US" sz="950" dirty="0"/>
           </a:p>
@@ -5447,7 +5447,7 @@
                 <a:ea typeface="Courier New" pitchFamily="34" charset="-122"/>
                 <a:cs typeface="Courier New" pitchFamily="34" charset="-120"/>
               </a:rPr>
-              <a:t>    CreateAsync(CancellationToken ct = default)</a:t>
+              <a:t>        ChatClientFactory.Create();</a:t>
             </a:r>
             <a:endParaRPr lang="en-US" sz="950" dirty="0"/>
           </a:p>
@@ -5467,7 +5467,7 @@
                 <a:ea typeface="Courier New" pitchFamily="34" charset="-122"/>
                 <a:cs typeface="Courier New" pitchFamily="34" charset="-120"/>
               </a:rPr>
-              <a:t>{</a:t>
+              <a:t>    AIAgent agent = new ChatClientAgent(</a:t>
             </a:r>
             <a:endParaRPr lang="en-US" sz="950" dirty="0"/>
           </a:p>
@@ -5487,7 +5487,7 @@
                 <a:ea typeface="Courier New" pitchFamily="34" charset="-122"/>
                 <a:cs typeface="Courier New" pitchFamily="34" charset="-120"/>
               </a:rPr>
-              <a:t>    string apiKey = Environment</a:t>
+              <a:t>        chatClient, Instructions, name: "MiniCode");</a:t>
             </a:r>
             <a:endParaRPr lang="en-US" sz="950" dirty="0"/>
           </a:p>
@@ -5507,7 +5507,7 @@
                 <a:ea typeface="Courier New" pitchFamily="34" charset="-122"/>
                 <a:cs typeface="Courier New" pitchFamily="34" charset="-120"/>
               </a:rPr>
-              <a:t>        .GetEnvironmentVariable(ApiKeyVariable)</a:t>
+              <a:t>    AgentSession session =</a:t>
             </a:r>
             <a:endParaRPr lang="en-US" sz="950" dirty="0"/>
           </a:p>
@@ -5527,10 +5527,32 @@
                 <a:ea typeface="Courier New" pitchFamily="34" charset="-122"/>
                 <a:cs typeface="Courier New" pitchFamily="34" charset="-120"/>
               </a:rPr>
-              <a:t>        ?? throw new InvalidOperationException(...);</a:t>
+              <a:t>        await agent.CreateSessionAsync(ct);</a:t>
             </a:r>
             <a:endParaRPr lang="en-US" sz="950" dirty="0"/>
           </a:p>
+        </p:txBody>
+      </p:sp>
+      <p:sp>
+        <p:nvSpPr>
+          <p:cNvPr id="18" name="Text 16"/>
+          <p:cNvSpPr txBox="1"/>
+          <p:nvPr/>
+        </p:nvSpPr>
+        <p:spPr>
+          <a:xfrm>
+            <a:off x="6638544" y="3685032"/>
+            <a:ext cx="4690872" cy="377952"/>
+          </a:xfrm>
+          <a:prstGeom prst="rect">
+            <a:avLst/>
+          </a:prstGeom>
+          <a:noFill/>
+          <a:ln/>
+        </p:spPr>
+        <p:txBody>
+          <a:bodyPr wrap="square" lIns="0" tIns="0" rIns="0" bIns="0" rtlCol="0" anchor="t"/>
+          <a:lstStyle/>
           <a:p>
             <a:pPr indent="0" marL="0">
               <a:lnSpc>
@@ -5541,13 +5563,13 @@
             <a:r>
               <a:rPr lang="en-US" sz="950" dirty="0">
                 <a:solidFill>
-                  <a:srgbClr val="CADCFC"/>
+                  <a:srgbClr val="3FBFB0"/>
                 </a:solidFill>
                 <a:latin typeface="Courier New" pitchFamily="34" charset="0"/>
                 <a:ea typeface="Courier New" pitchFamily="34" charset="-122"/>
                 <a:cs typeface="Courier New" pitchFamily="34" charset="-120"/>
               </a:rPr>
-              <a:t>    IChatClient chatClient = new OpenAIClient(</a:t>
+              <a:t>    return new CodingAgent(</a:t>
             </a:r>
             <a:endParaRPr lang="en-US" sz="950" dirty="0"/>
           </a:p>
@@ -5561,178 +5583,16 @@
             <a:r>
               <a:rPr lang="en-US" sz="950" dirty="0">
                 <a:solidFill>
-                  <a:srgbClr val="CADCFC"/>
+                  <a:srgbClr val="3FBFB0"/>
                 </a:solidFill>
                 <a:latin typeface="Courier New" pitchFamily="34" charset="0"/>
                 <a:ea typeface="Courier New" pitchFamily="34" charset="-122"/>
                 <a:cs typeface="Courier New" pitchFamily="34" charset="-120"/>
               </a:rPr>
-              <a:t>        apiKey).GetChatClient(ModelId)</a:t>
+              <a:t>        agent, session, chatClient);</a:t>
             </a:r>
             <a:endParaRPr lang="en-US" sz="950" dirty="0"/>
           </a:p>
-          <a:p>
-            <a:pPr indent="0" marL="0">
-              <a:lnSpc>
-                <a:spcPts val="1200"/>
-              </a:lnSpc>
-              <a:buNone/>
-            </a:pPr>
-            <a:r>
-              <a:rPr lang="en-US" sz="950" dirty="0">
-                <a:solidFill>
-                  <a:srgbClr val="CADCFC"/>
-                </a:solidFill>
-                <a:latin typeface="Courier New" pitchFamily="34" charset="0"/>
-                <a:ea typeface="Courier New" pitchFamily="34" charset="-122"/>
-                <a:cs typeface="Courier New" pitchFamily="34" charset="-120"/>
-              </a:rPr>
-              <a:t>        .AsIChatClient();</a:t>
-            </a:r>
-            <a:endParaRPr lang="en-US" sz="950" dirty="0"/>
-          </a:p>
-          <a:p>
-            <a:pPr indent="0" marL="0">
-              <a:lnSpc>
-                <a:spcPts val="1200"/>
-              </a:lnSpc>
-              <a:buNone/>
-            </a:pPr>
-            <a:r>
-              <a:rPr lang="en-US" sz="950" dirty="0">
-                <a:solidFill>
-                  <a:srgbClr val="CADCFC"/>
-                </a:solidFill>
-                <a:latin typeface="Courier New" pitchFamily="34" charset="0"/>
-                <a:ea typeface="Courier New" pitchFamily="34" charset="-122"/>
-                <a:cs typeface="Courier New" pitchFamily="34" charset="-120"/>
-              </a:rPr>
-              <a:t>    AIAgent agent = new ChatClientAgent(</a:t>
-            </a:r>
-            <a:endParaRPr lang="en-US" sz="950" dirty="0"/>
-          </a:p>
-          <a:p>
-            <a:pPr indent="0" marL="0">
-              <a:lnSpc>
-                <a:spcPts val="1200"/>
-              </a:lnSpc>
-              <a:buNone/>
-            </a:pPr>
-            <a:r>
-              <a:rPr lang="en-US" sz="950" dirty="0">
-                <a:solidFill>
-                  <a:srgbClr val="CADCFC"/>
-                </a:solidFill>
-                <a:latin typeface="Courier New" pitchFamily="34" charset="0"/>
-                <a:ea typeface="Courier New" pitchFamily="34" charset="-122"/>
-                <a:cs typeface="Courier New" pitchFamily="34" charset="-120"/>
-              </a:rPr>
-              <a:t>        chatClient, Instructions, name: "MiniCode");</a:t>
-            </a:r>
-            <a:endParaRPr lang="en-US" sz="950" dirty="0"/>
-          </a:p>
-          <a:p>
-            <a:pPr indent="0" marL="0">
-              <a:lnSpc>
-                <a:spcPts val="1200"/>
-              </a:lnSpc>
-              <a:buNone/>
-            </a:pPr>
-            <a:r>
-              <a:rPr lang="en-US" sz="950" dirty="0">
-                <a:solidFill>
-                  <a:srgbClr val="CADCFC"/>
-                </a:solidFill>
-                <a:latin typeface="Courier New" pitchFamily="34" charset="0"/>
-                <a:ea typeface="Courier New" pitchFamily="34" charset="-122"/>
-                <a:cs typeface="Courier New" pitchFamily="34" charset="-120"/>
-              </a:rPr>
-              <a:t>    AgentSession session =</a:t>
-            </a:r>
-            <a:endParaRPr lang="en-US" sz="950" dirty="0"/>
-          </a:p>
-          <a:p>
-            <a:pPr indent="0" marL="0">
-              <a:lnSpc>
-                <a:spcPts val="1200"/>
-              </a:lnSpc>
-              <a:buNone/>
-            </a:pPr>
-            <a:r>
-              <a:rPr lang="en-US" sz="950" dirty="0">
-                <a:solidFill>
-                  <a:srgbClr val="CADCFC"/>
-                </a:solidFill>
-                <a:latin typeface="Courier New" pitchFamily="34" charset="0"/>
-                <a:ea typeface="Courier New" pitchFamily="34" charset="-122"/>
-                <a:cs typeface="Courier New" pitchFamily="34" charset="-120"/>
-              </a:rPr>
-              <a:t>        await agent.CreateSessionAsync(ct);</a:t>
-            </a:r>
-            <a:endParaRPr lang="en-US" sz="950" dirty="0"/>
-          </a:p>
-        </p:txBody>
-      </p:sp>
-      <p:sp>
-        <p:nvSpPr>
-          <p:cNvPr id="18" name="Text 16"/>
-          <p:cNvSpPr txBox="1"/>
-          <p:nvPr/>
-        </p:nvSpPr>
-        <p:spPr>
-          <a:xfrm>
-            <a:off x="6638544" y="4751832"/>
-            <a:ext cx="4690872" cy="377952"/>
-          </a:xfrm>
-          <a:prstGeom prst="rect">
-            <a:avLst/>
-          </a:prstGeom>
-          <a:noFill/>
-          <a:ln/>
-        </p:spPr>
-        <p:txBody>
-          <a:bodyPr wrap="square" lIns="0" tIns="0" rIns="0" bIns="0" rtlCol="0" anchor="t"/>
-          <a:lstStyle/>
-          <a:p>
-            <a:pPr indent="0" marL="0">
-              <a:lnSpc>
-                <a:spcPts val="1200"/>
-              </a:lnSpc>
-              <a:buNone/>
-            </a:pPr>
-            <a:r>
-              <a:rPr lang="en-US" sz="950" dirty="0">
-                <a:solidFill>
-                  <a:srgbClr val="3FBFB0"/>
-                </a:solidFill>
-                <a:latin typeface="Courier New" pitchFamily="34" charset="0"/>
-                <a:ea typeface="Courier New" pitchFamily="34" charset="-122"/>
-                <a:cs typeface="Courier New" pitchFamily="34" charset="-120"/>
-              </a:rPr>
-              <a:t>    return new CodingAgent(</a:t>
-            </a:r>
-            <a:endParaRPr lang="en-US" sz="950" dirty="0"/>
-          </a:p>
-          <a:p>
-            <a:pPr indent="0" marL="0">
-              <a:lnSpc>
-                <a:spcPts val="1200"/>
-              </a:lnSpc>
-              <a:buNone/>
-            </a:pPr>
-            <a:r>
-              <a:rPr lang="en-US" sz="950" dirty="0">
-                <a:solidFill>
-                  <a:srgbClr val="3FBFB0"/>
-                </a:solidFill>
-                <a:latin typeface="Courier New" pitchFamily="34" charset="0"/>
-                <a:ea typeface="Courier New" pitchFamily="34" charset="-122"/>
-                <a:cs typeface="Courier New" pitchFamily="34" charset="-120"/>
-              </a:rPr>
-              <a:t>        agent, session, chatClient);</a:t>
-            </a:r>
-            <a:endParaRPr lang="en-US" sz="950" dirty="0"/>
-          </a:p>
         </p:txBody>
       </p:sp>
       <p:sp>
@@ -5743,7 +5603,7 @@
         </p:nvSpPr>
         <p:spPr>
           <a:xfrm>
-            <a:off x="6638544" y="5056632"/>
+            <a:off x="6638544" y="3989832"/>
             <a:ext cx="4690872" cy="225552"/>
           </a:xfrm>
           <a:prstGeom prst="rect">
@@ -6332,7 +6192,7 @@
                 <a:ea typeface="Calibri" pitchFamily="34" charset="-122"/>
                 <a:cs typeface="Calibri" pitchFamily="34" charset="-120"/>
               </a:rPr>
-              <a:t>Module 2 created it in Main; it now lives on the class that uses it. That relocation is why Module 8 can later replace the conversation without touching the loop.</a:t>
+              <a:t>Module 2a created it in Main; it now lives on the class that uses it. That relocation is why Module 8 can later replace the conversation without touching the loop.</a:t>
             </a:r>
             <a:endParaRPr lang="en-US" sz="1050" dirty="0"/>
           </a:p>
@@ -6666,7 +6526,7 @@
                 <a:ea typeface="Calibri" pitchFamily="34" charset="-122"/>
                 <a:cs typeface="Calibri" pitchFamily="34" charset="-120"/>
               </a:rPr>
-              <a:t>The only place that mentions OpenAI or reads an environment variable. When Module 5a adds tools, they get wired in here.</a:t>
+              <a:t>It never names a provider: the IChatClient comes from ChatClientFactory. When Module 5a adds tools, they get wired in here.</a:t>
             </a:r>
             <a:endParaRPr lang="en-US" sz="1050" dirty="0"/>
           </a:p>
@@ -7142,7 +7002,7 @@
                 <a:ea typeface="Calibri" pitchFamily="34" charset="-122"/>
                 <a:cs typeface="Calibri" pitchFamily="34" charset="-120"/>
               </a:rPr>
-              <a:t>Identical behaviour to Module 2, which is the point: a refactor that changes structure and not function.</a:t>
+              <a:t>Identical behaviour to Module 2b, which is the point: a refactor that changes structure and not function.</a:t>
             </a:r>
             <a:endParaRPr lang="en-US" sz="1250" dirty="0"/>
           </a:p>
@@ -7367,7 +7227,7 @@
                 <a:ea typeface="Calibri" pitchFamily="34" charset="-122"/>
                 <a:cs typeface="Calibri" pitchFamily="34" charset="-120"/>
               </a:rPr>
-              <a:t>Program.cs already calls new ConsoleChatLoop(agent).RunAsync(), and that class does not exist yet. Move Module 2's read-evaluate-print loop into src/MiniCode.Cli/ConsoleChatLoop.cs.</a:t>
+              <a:t>Program.cs already calls new ConsoleChatLoop(agent).RunAsync(), and that class does not exist yet. Move Module 2b's read-evaluate-print loop into src/MiniCode.Cli/ConsoleChatLoop.cs.</a:t>
             </a:r>
             <a:endParaRPr lang="en-US" sz="1350" dirty="0"/>
           </a:p>

</xml_diff>